<commit_message>
Weiterspielen nur mit Name + persönlichem Code (ohne Kurscode)
- Anmeldung: kursübergreifende Suche nach Name + Code; Kurscode nur noch, wenn beides zu mehreren Kursen
  passt (nur bei alten, doppelt vergebenen Codes möglich) – Startseite blendet das Feld dann ein (409 kurscodeNoetig)
- Neue Codes werden kursübergreifend eindeutig vergeben (Beitritt und „neuer Code“); Index auf schueler.code
- Rate-Limit je Name statt je Kurscode + Name
- Texte in Lab, README und Materialien angepasst (Im-Lab-üben-Kästen, Kickoff-Folie inkl. Screenshot,
  Lehrerhinweise, Gesamtübersicht); PDFs neu erzeugt; Tests; Version 2.3.0

Co-Authored-By: Claude Opus 5.5 <noreply@anthropic.com>
Claude-Session: https://claude.ai/code/session_01CemoEYGRdCe5FszEBVFFUP
</commit_message>
<xml_diff>
--- a/materialien/Welt0_Akademie/1_Praesentation/AQ_W0_Kickoff.pptx
+++ b/materialien/Welt0_Akademie/1_Praesentation/AQ_W0_Kickoff.pptx
@@ -1188,7 +1188,7 @@
           <a:p>
             <a:r>
               <a:rPr lang="en-US" dirty="0"/>
-              <a:t>Werkzeuge (ca. 2 min): Programmiert wird in der Online-IDE im Browser, Tests laufen im Reiter Testrunner – die IDE bleibt extern und vergibt keine Punkte. Das Algo Quest Lab ist unsere Übungsplattform: Weltkarte mit Lab-Leveln, automatisch geprüfte Aufgaben, Punkte, Rang und Abzeichen, Online-Boss, Trainingsplatz und Warm-up-Trainer; Anmeldung mit Kurscode, Name und persönlichem Code. Die YouTube-Playlist enthält Erklärvideos und Boss-Lösungen. Vor dem Einsatz algoquest.frankjuchim.de durch die echte Adresse und den QR-Platzhalter durch den Playlist-Link ersetzen.</a:t>
+              <a:t>Werkzeuge (ca. 2 min): Programmiert wird in der Online-IDE im Browser, Tests laufen im Reiter Testrunner – die IDE bleibt extern und vergibt keine Punkte. Das Algo Quest Lab ist unsere Übungsplattform: Weltkarte mit Lab-Leveln, automatisch geprüfte Aufgaben, Punkte, Rang und Abzeichen, Online-Boss, Trainingsplatz und Warm-up-Trainer; Beitritt mit Kurscode und Name, danach Anmeldung mit Name und persönlichem Code. Die YouTube-Playlist enthält Erklärvideos und Boss-Lösungen. Vor dem Einsatz algoquest.frankjuchim.de durch die echte Adresse und den QR-Platzhalter durch den Playlist-Link ersetzen.</a:t>
             </a:r>
             <a:endParaRPr lang="en-US" dirty="0"/>
           </a:p>
@@ -2068,7 +2068,7 @@
           <a:p>
             <a:r>
               <a:rPr lang="en-US" dirty="0"/>
-              <a:t>Beitritt ins Algo Quest Lab (ca. 3 min): Vorher im Lehrkraft-Bereich den Kurs anlegen und unter „Beitritt &amp; QR“ den QR-Code am Beamer zeigen; algoquest.frankjuchim.de vor dem Einsatz durch die echte Adresse ersetzen. Alle öffnen das Lab, tippen den Kurscode und ihren Namen ein – Vorname plus Initial des Nachnamens, z. B. „Lena S.“. Danach zeigt das Lab den persönlichen Code: unbedingt notieren oder fotografieren. Mit Kurscode, Name und Code kann man auf jedem Gerät weiterspielen. Wer den Code verliert, bekommt von mir in der Schülerliste einen neuen.</a:t>
+              <a:t>Beitritt ins Algo Quest Lab (ca. 3 min): Vorher im Lehrkraft-Bereich den Kurs anlegen und unter „Beitritt &amp; QR“ den QR-Code am Beamer zeigen; algoquest.frankjuchim.de vor dem Einsatz durch die echte Adresse ersetzen. Alle öffnen das Lab, tippen den Kurscode und ihren Namen ein – Vorname plus Initial des Nachnamens, z. B. „Lena S.“. Danach zeigt das Lab den persönlichen Code: unbedingt notieren oder fotografieren. Mit Name und Code kann man auf jedem Gerät weiterspielen. Wer den Code verliert, bekommt von mir in der Schülerliste einen neuen.</a:t>
             </a:r>
             <a:endParaRPr lang="en-US" dirty="0"/>
           </a:p>
@@ -10697,7 +10697,7 @@
                   <a:schemeClr val="accent6"/>
                 </a:solidFill>
               </a:rPr>
-              <a:t>Kurscode + Name + Code</a:t>
+              <a:t>Kurscode + Name → persönlicher Code</a:t>
             </a:r>
             <a:endParaRPr lang="en-US" sz="1800" dirty="0"/>
           </a:p>
@@ -20563,7 +20563,7 @@
                   <a:schemeClr val="tx1"/>
                 </a:solidFill>
               </a:rPr>
-              <a:t>Du bekommst einen persönlichen Code, z. B. K7M-42Q – ins Heft schreiben oder fotografieren</a:t>
+              <a:t>Du bekommst einen persönlichen Code, z. B. KMQ-427 – ins Heft schreiben oder fotografieren</a:t>
             </a:r>
             <a:endParaRPr lang="en-US" sz="1800" dirty="0"/>
           </a:p>
@@ -20621,7 +20621,7 @@
                   <a:schemeClr val="accent1"/>
                 </a:solidFill>
               </a:rPr>
-              <a:t>Weiterspielen auf jedem Gerät: </a:t>
+              <a:t>Weiterspielen auf jedem Gerät: Name + Code</a:t>
             </a:r>
             <a:pPr indent="0" marL="0">
               <a:buNone/>
@@ -20632,7 +20632,7 @@
                   <a:schemeClr val="tx1"/>
                 </a:solidFill>
               </a:rPr>
-              <a:t>Kurscode + Name + Code.</a:t>
+              <a:t>.</a:t>
             </a:r>
             <a:endParaRPr lang="en-US" sz="1900" dirty="0"/>
           </a:p>
@@ -20655,7 +20655,7 @@
         <p:spPr>
           <a:xfrm>
             <a:off x="7452360" y="1371600"/>
-            <a:ext cx="4160520" cy="3410712"/>
+            <a:ext cx="4160520" cy="3039953"/>
           </a:xfrm>
           <a:prstGeom prst="rect">
             <a:avLst/>

</xml_diff>